<commit_message>
docs(pitch): 심사평 반영 v3 덱 (2장 HTML/PDF), pptx 비교표·GTM 순서 수정
- 한 줄 소개 통일, 데이터 출처와 우리만 갖는 데이터, 실측 백테스트 25~31%
- 고객 순서를 RL 평가·데이터 회사 → 농장(무료) → 보험사 파일럿으로
- 새 캡처: 3D 농장 지도, 실데이터 채점 화면

Co-Authored-By: Claude Opus 5.5 <noreply@anthropic.com>
</commit_message>
<xml_diff>
--- a/docs/pitch/weather-decision-gym.pptx
+++ b/docs/pitch/weather-decision-gym.pptx
@@ -7,6 +7,8 @@
   <p:sldIdLst>
     <p:sldId id="256" r:id="rId7"/>
     <p:sldId id="257" r:id="rId8"/>
+    <p:sldId id="258" r:id="rId9"/>
+    <p:sldId id="259" r:id="rId10"/>
   </p:sldIdLst>
   <p:sldSz cx="12191695" cy="6858000" type="screen4x3"/>
   <p:notesSz cx="6858000" cy="9144000"/>
@@ -4580,6 +4582,2116 @@
                 <a:latin typeface="Malgun Gothic"/>
               </a:rPr>
               <a:t>검증된 날씨-생산량 데이터는 기업의 자산이 되어 작물 생산량을 높이고 보험사의 지출을 줄인다.   (데모 수치는 임의의 아이오와 농장 목업, 비용·가격은 가정)</a:t>
+            </a:r>
+          </a:p>
+        </p:txBody>
+      </p:sp>
+    </p:spTree>
+  </p:cSld>
+  <p:clrMapOvr>
+    <a:masterClrMapping/>
+  </p:clrMapOvr>
+</p:sld>
+</file>
+
+<file path=ppt/slides/slide3.xml><?xml version="1.0" encoding="utf-8"?>
+<p:sld xmlns:a="http://schemas.openxmlformats.org/drawingml/2006/main" xmlns:p="http://schemas.openxmlformats.org/presentationml/2006/main" xmlns:r="http://schemas.openxmlformats.org/officeDocument/2006/relationships">
+  <p:cSld>
+    <p:bg>
+      <p:bgPr>
+        <a:solidFill>
+          <a:srgbClr val="E9ECE6"/>
+        </a:solidFill>
+        <a:effectLst/>
+      </p:bgPr>
+    </p:bg>
+    <p:spTree>
+      <p:nvGrpSpPr>
+        <p:cNvPr id="1" name=""/>
+        <p:cNvGrpSpPr/>
+        <p:nvPr/>
+      </p:nvGrpSpPr>
+      <p:grpSpPr/>
+      <p:sp>
+        <p:nvSpPr>
+          <p:cNvPr id="2" name="TextBox 1"/>
+          <p:cNvSpPr txBox="1"/>
+          <p:nvPr/>
+        </p:nvSpPr>
+        <p:spPr>
+          <a:xfrm>
+            <a:off x="548640" y="320040"/>
+            <a:ext cx="7315200" cy="365760"/>
+          </a:xfrm>
+          <a:prstGeom prst="rect">
+            <a:avLst/>
+          </a:prstGeom>
+          <a:noFill/>
+        </p:spPr>
+        <p:txBody>
+          <a:bodyPr wrap="square">
+            <a:spAutoFit/>
+          </a:bodyPr>
+          <a:lstStyle/>
+          <a:p>
+            <a:pPr algn="l">
+              <a:lnSpc>
+                <a:spcPct val="110000"/>
+              </a:lnSpc>
+            </a:pPr>
+            <a:r>
+              <a:rPr sz="1200" b="1">
+                <a:solidFill>
+                  <a:srgbClr val="4A5650"/>
+                </a:solidFill>
+                <a:latin typeface="Malgun Gothic"/>
+              </a:rPr>
+              <a:t>Weather Decision Gym · 꺄레</a:t>
+            </a:r>
+          </a:p>
+        </p:txBody>
+      </p:sp>
+      <p:cxnSp>
+        <p:nvCxnSpPr>
+          <p:cNvPr id="3" name="Connector 2"/>
+          <p:cNvCxnSpPr/>
+          <p:nvPr/>
+        </p:nvCxnSpPr>
+        <p:spPr>
+          <a:xfrm>
+            <a:off x="548640" y="731520"/>
+            <a:ext cx="11064240" cy="0"/>
+          </a:xfrm>
+          <a:prstGeom prst="line">
+            <a:avLst/>
+          </a:prstGeom>
+          <a:ln w="25400">
+            <a:solidFill>
+              <a:srgbClr val="1C2620"/>
+            </a:solidFill>
+          </a:ln>
+        </p:spPr>
+        <p:style>
+          <a:lnRef idx="2">
+            <a:schemeClr val="accent1"/>
+          </a:lnRef>
+          <a:fillRef idx="0">
+            <a:schemeClr val="accent1"/>
+          </a:fillRef>
+          <a:effectRef idx="1">
+            <a:schemeClr val="accent1"/>
+          </a:effectRef>
+          <a:fontRef idx="minor">
+            <a:schemeClr val="tx1"/>
+          </a:fontRef>
+        </p:style>
+      </p:cxnSp>
+      <p:sp>
+        <p:nvSpPr>
+          <p:cNvPr id="4" name="TextBox 3"/>
+          <p:cNvSpPr txBox="1"/>
+          <p:nvPr/>
+        </p:nvSpPr>
+        <p:spPr>
+          <a:xfrm>
+            <a:off x="548640" y="868680"/>
+            <a:ext cx="11064240" cy="1097280"/>
+          </a:xfrm>
+          <a:prstGeom prst="rect">
+            <a:avLst/>
+          </a:prstGeom>
+          <a:noFill/>
+        </p:spPr>
+        <p:txBody>
+          <a:bodyPr wrap="square">
+            <a:spAutoFit/>
+          </a:bodyPr>
+          <a:lstStyle/>
+          <a:p>
+            <a:pPr algn="l">
+              <a:lnSpc>
+                <a:spcPct val="105000"/>
+              </a:lnSpc>
+            </a:pPr>
+            <a:r>
+              <a:rPr sz="2800" b="1">
+                <a:solidFill>
+                  <a:srgbClr val="1C2620"/>
+                </a:solidFill>
+                <a:latin typeface="Malgun Gothic"/>
+              </a:rPr>
+              <a:t>예보는 이미 무료가 되고 있다.</a:t>
+            </a:r>
+          </a:p>
+          <a:p>
+            <a:pPr algn="l">
+              <a:lnSpc>
+                <a:spcPct val="105000"/>
+              </a:lnSpc>
+            </a:pPr>
+            <a:r>
+              <a:rPr sz="2800" b="1">
+                <a:solidFill>
+                  <a:srgbClr val="1C2620"/>
+                </a:solidFill>
+                <a:latin typeface="Malgun Gothic"/>
+              </a:rPr>
+              <a:t>우리는 예보가 아니라 "필지별로 맞았는지"의 기록을 판다.</a:t>
+            </a:r>
+          </a:p>
+        </p:txBody>
+      </p:sp>
+      <p:sp>
+        <p:nvSpPr>
+          <p:cNvPr id="5" name="TextBox 4"/>
+          <p:cNvSpPr txBox="1"/>
+          <p:nvPr/>
+        </p:nvSpPr>
+        <p:spPr>
+          <a:xfrm>
+            <a:off x="548640" y="2240280"/>
+            <a:ext cx="2194560" cy="548640"/>
+          </a:xfrm>
+          <a:prstGeom prst="rect">
+            <a:avLst/>
+          </a:prstGeom>
+          <a:noFill/>
+        </p:spPr>
+        <p:txBody>
+          <a:bodyPr wrap="square">
+            <a:spAutoFit/>
+          </a:bodyPr>
+          <a:lstStyle/>
+          <a:p>
+            <a:pPr algn="l">
+              <a:lnSpc>
+                <a:spcPct val="110000"/>
+              </a:lnSpc>
+            </a:pPr>
+            <a:r>
+              <a:rPr sz="1100" b="1">
+                <a:solidFill>
+                  <a:srgbClr val="4A5650"/>
+                </a:solidFill>
+                <a:latin typeface="Malgun Gothic"/>
+              </a:rPr>
+              <a:t/>
+            </a:r>
+          </a:p>
+        </p:txBody>
+      </p:sp>
+      <p:sp>
+        <p:nvSpPr>
+          <p:cNvPr id="6" name="TextBox 5"/>
+          <p:cNvSpPr txBox="1"/>
+          <p:nvPr/>
+        </p:nvSpPr>
+        <p:spPr>
+          <a:xfrm>
+            <a:off x="2834640" y="2240280"/>
+            <a:ext cx="3657600" cy="548640"/>
+          </a:xfrm>
+          <a:prstGeom prst="rect">
+            <a:avLst/>
+          </a:prstGeom>
+          <a:noFill/>
+        </p:spPr>
+        <p:txBody>
+          <a:bodyPr wrap="square">
+            <a:spAutoFit/>
+          </a:bodyPr>
+          <a:lstStyle/>
+          <a:p>
+            <a:pPr algn="l">
+              <a:lnSpc>
+                <a:spcPct val="110000"/>
+              </a:lnSpc>
+            </a:pPr>
+            <a:r>
+              <a:rPr sz="1100" b="1">
+                <a:solidFill>
+                  <a:srgbClr val="4A5650"/>
+                </a:solidFill>
+                <a:latin typeface="Malgun Gothic"/>
+              </a:rPr>
+              <a:t>파는 것</a:t>
+            </a:r>
+          </a:p>
+        </p:txBody>
+      </p:sp>
+      <p:sp>
+        <p:nvSpPr>
+          <p:cNvPr id="7" name="TextBox 6"/>
+          <p:cNvSpPr txBox="1"/>
+          <p:nvPr/>
+        </p:nvSpPr>
+        <p:spPr>
+          <a:xfrm>
+            <a:off x="6583680" y="2240280"/>
+            <a:ext cx="1280160" cy="548640"/>
+          </a:xfrm>
+          <a:prstGeom prst="rect">
+            <a:avLst/>
+          </a:prstGeom>
+          <a:noFill/>
+        </p:spPr>
+        <p:txBody>
+          <a:bodyPr wrap="square">
+            <a:spAutoFit/>
+          </a:bodyPr>
+          <a:lstStyle/>
+          <a:p>
+            <a:pPr algn="l">
+              <a:lnSpc>
+                <a:spcPct val="110000"/>
+              </a:lnSpc>
+            </a:pPr>
+            <a:r>
+              <a:rPr sz="1100" b="1">
+                <a:solidFill>
+                  <a:srgbClr val="4A5650"/>
+                </a:solidFill>
+                <a:latin typeface="Malgun Gothic"/>
+              </a:rPr>
+              <a:t>단위</a:t>
+            </a:r>
+          </a:p>
+        </p:txBody>
+      </p:sp>
+      <p:sp>
+        <p:nvSpPr>
+          <p:cNvPr id="8" name="TextBox 7"/>
+          <p:cNvSpPr txBox="1"/>
+          <p:nvPr/>
+        </p:nvSpPr>
+        <p:spPr>
+          <a:xfrm>
+            <a:off x="7955279" y="2240280"/>
+            <a:ext cx="3657600" cy="548640"/>
+          </a:xfrm>
+          <a:prstGeom prst="rect">
+            <a:avLst/>
+          </a:prstGeom>
+          <a:noFill/>
+        </p:spPr>
+        <p:txBody>
+          <a:bodyPr wrap="square">
+            <a:spAutoFit/>
+          </a:bodyPr>
+          <a:lstStyle/>
+          <a:p>
+            <a:pPr algn="l">
+              <a:lnSpc>
+                <a:spcPct val="110000"/>
+              </a:lnSpc>
+            </a:pPr>
+            <a:r>
+              <a:rPr sz="1100" b="1">
+                <a:solidFill>
+                  <a:srgbClr val="4A5650"/>
+                </a:solidFill>
+                <a:latin typeface="Malgun Gothic"/>
+              </a:rPr>
+              <a:t>시즌이 지나면</a:t>
+            </a:r>
+          </a:p>
+        </p:txBody>
+      </p:sp>
+      <p:cxnSp>
+        <p:nvCxnSpPr>
+          <p:cNvPr id="9" name="Connector 8"/>
+          <p:cNvCxnSpPr/>
+          <p:nvPr/>
+        </p:nvCxnSpPr>
+        <p:spPr>
+          <a:xfrm>
+            <a:off x="548640" y="2770632"/>
+            <a:ext cx="11064240" cy="0"/>
+          </a:xfrm>
+          <a:prstGeom prst="line">
+            <a:avLst/>
+          </a:prstGeom>
+          <a:ln w="12700">
+            <a:solidFill>
+              <a:srgbClr val="C5CCC3"/>
+            </a:solidFill>
+          </a:ln>
+        </p:spPr>
+        <p:style>
+          <a:lnRef idx="2">
+            <a:schemeClr val="accent1"/>
+          </a:lnRef>
+          <a:fillRef idx="0">
+            <a:schemeClr val="accent1"/>
+          </a:fillRef>
+          <a:effectRef idx="1">
+            <a:schemeClr val="accent1"/>
+          </a:effectRef>
+          <a:fontRef idx="minor">
+            <a:schemeClr val="tx1"/>
+          </a:fontRef>
+        </p:style>
+      </p:cxnSp>
+      <p:sp>
+        <p:nvSpPr>
+          <p:cNvPr id="10" name="TextBox 9"/>
+          <p:cNvSpPr txBox="1"/>
+          <p:nvPr/>
+        </p:nvSpPr>
+        <p:spPr>
+          <a:xfrm>
+            <a:off x="548640" y="2807208"/>
+            <a:ext cx="2194560" cy="548640"/>
+          </a:xfrm>
+          <a:prstGeom prst="rect">
+            <a:avLst/>
+          </a:prstGeom>
+          <a:noFill/>
+        </p:spPr>
+        <p:txBody>
+          <a:bodyPr wrap="square">
+            <a:spAutoFit/>
+          </a:bodyPr>
+          <a:lstStyle/>
+          <a:p>
+            <a:pPr algn="l">
+              <a:lnSpc>
+                <a:spcPct val="110000"/>
+              </a:lnSpc>
+            </a:pPr>
+            <a:r>
+              <a:rPr sz="1300" b="1">
+                <a:solidFill>
+                  <a:srgbClr val="1C2620"/>
+                </a:solidFill>
+                <a:latin typeface="Malgun Gothic"/>
+              </a:rPr>
+              <a:t>DTN · Tomorrow.io</a:t>
+            </a:r>
+          </a:p>
+        </p:txBody>
+      </p:sp>
+      <p:sp>
+        <p:nvSpPr>
+          <p:cNvPr id="11" name="TextBox 10"/>
+          <p:cNvSpPr txBox="1"/>
+          <p:nvPr/>
+        </p:nvSpPr>
+        <p:spPr>
+          <a:xfrm>
+            <a:off x="2834640" y="2807208"/>
+            <a:ext cx="3657600" cy="548640"/>
+          </a:xfrm>
+          <a:prstGeom prst="rect">
+            <a:avLst/>
+          </a:prstGeom>
+          <a:noFill/>
+        </p:spPr>
+        <p:txBody>
+          <a:bodyPr wrap="square">
+            <a:spAutoFit/>
+          </a:bodyPr>
+          <a:lstStyle/>
+          <a:p>
+            <a:pPr algn="l">
+              <a:lnSpc>
+                <a:spcPct val="110000"/>
+              </a:lnSpc>
+            </a:pPr>
+            <a:r>
+              <a:rPr sz="1300" b="0">
+                <a:solidFill>
+                  <a:srgbClr val="1C2620"/>
+                </a:solidFill>
+                <a:latin typeface="Malgun Gothic"/>
+              </a:rPr>
+              <a:t>더 정확한 예보 (API, 알림)</a:t>
+            </a:r>
+          </a:p>
+        </p:txBody>
+      </p:sp>
+      <p:sp>
+        <p:nvSpPr>
+          <p:cNvPr id="12" name="TextBox 11"/>
+          <p:cNvSpPr txBox="1"/>
+          <p:nvPr/>
+        </p:nvSpPr>
+        <p:spPr>
+          <a:xfrm>
+            <a:off x="6583680" y="2807208"/>
+            <a:ext cx="1280160" cy="548640"/>
+          </a:xfrm>
+          <a:prstGeom prst="rect">
+            <a:avLst/>
+          </a:prstGeom>
+          <a:noFill/>
+        </p:spPr>
+        <p:txBody>
+          <a:bodyPr wrap="square">
+            <a:spAutoFit/>
+          </a:bodyPr>
+          <a:lstStyle/>
+          <a:p>
+            <a:pPr algn="l">
+              <a:lnSpc>
+                <a:spcPct val="110000"/>
+              </a:lnSpc>
+            </a:pPr>
+            <a:r>
+              <a:rPr sz="1300" b="0">
+                <a:solidFill>
+                  <a:srgbClr val="1C2620"/>
+                </a:solidFill>
+                <a:latin typeface="Malgun Gothic"/>
+              </a:rPr>
+              <a:t>격자·지역</a:t>
+            </a:r>
+          </a:p>
+        </p:txBody>
+      </p:sp>
+      <p:sp>
+        <p:nvSpPr>
+          <p:cNvPr id="13" name="TextBox 12"/>
+          <p:cNvSpPr txBox="1"/>
+          <p:nvPr/>
+        </p:nvSpPr>
+        <p:spPr>
+          <a:xfrm>
+            <a:off x="7955279" y="2807208"/>
+            <a:ext cx="3657600" cy="548640"/>
+          </a:xfrm>
+          <a:prstGeom prst="rect">
+            <a:avLst/>
+          </a:prstGeom>
+          <a:noFill/>
+        </p:spPr>
+        <p:txBody>
+          <a:bodyPr wrap="square">
+            <a:spAutoFit/>
+          </a:bodyPr>
+          <a:lstStyle/>
+          <a:p>
+            <a:pPr algn="l">
+              <a:lnSpc>
+                <a:spcPct val="110000"/>
+              </a:lnSpc>
+            </a:pPr>
+            <a:r>
+              <a:rPr sz="1300" b="0">
+                <a:solidFill>
+                  <a:srgbClr val="1C2620"/>
+                </a:solidFill>
+                <a:latin typeface="Malgun Gothic"/>
+              </a:rPr>
+              <a:t>같은 정확도. 오픈 모델(NVIDIA Earth-2, WeatherNext)과 경쟁</a:t>
+            </a:r>
+          </a:p>
+        </p:txBody>
+      </p:sp>
+      <p:cxnSp>
+        <p:nvCxnSpPr>
+          <p:cNvPr id="14" name="Connector 13"/>
+          <p:cNvCxnSpPr/>
+          <p:nvPr/>
+        </p:nvCxnSpPr>
+        <p:spPr>
+          <a:xfrm>
+            <a:off x="548640" y="3337560"/>
+            <a:ext cx="11064240" cy="0"/>
+          </a:xfrm>
+          <a:prstGeom prst="line">
+            <a:avLst/>
+          </a:prstGeom>
+          <a:ln w="12700">
+            <a:solidFill>
+              <a:srgbClr val="C5CCC3"/>
+            </a:solidFill>
+          </a:ln>
+        </p:spPr>
+        <p:style>
+          <a:lnRef idx="2">
+            <a:schemeClr val="accent1"/>
+          </a:lnRef>
+          <a:fillRef idx="0">
+            <a:schemeClr val="accent1"/>
+          </a:fillRef>
+          <a:effectRef idx="1">
+            <a:schemeClr val="accent1"/>
+          </a:effectRef>
+          <a:fontRef idx="minor">
+            <a:schemeClr val="tx1"/>
+          </a:fontRef>
+        </p:style>
+      </p:cxnSp>
+      <p:sp>
+        <p:nvSpPr>
+          <p:cNvPr id="15" name="TextBox 14"/>
+          <p:cNvSpPr txBox="1"/>
+          <p:nvPr/>
+        </p:nvSpPr>
+        <p:spPr>
+          <a:xfrm>
+            <a:off x="548640" y="3374136"/>
+            <a:ext cx="2194560" cy="548640"/>
+          </a:xfrm>
+          <a:prstGeom prst="rect">
+            <a:avLst/>
+          </a:prstGeom>
+          <a:noFill/>
+        </p:spPr>
+        <p:txBody>
+          <a:bodyPr wrap="square">
+            <a:spAutoFit/>
+          </a:bodyPr>
+          <a:lstStyle/>
+          <a:p>
+            <a:pPr algn="l">
+              <a:lnSpc>
+                <a:spcPct val="110000"/>
+              </a:lnSpc>
+            </a:pPr>
+            <a:r>
+              <a:rPr sz="1300" b="1">
+                <a:solidFill>
+                  <a:srgbClr val="1C2620"/>
+                </a:solidFill>
+                <a:latin typeface="Malgun Gothic"/>
+              </a:rPr>
+              <a:t>Climate FieldView</a:t>
+            </a:r>
+          </a:p>
+        </p:txBody>
+      </p:sp>
+      <p:sp>
+        <p:nvSpPr>
+          <p:cNvPr id="16" name="TextBox 15"/>
+          <p:cNvSpPr txBox="1"/>
+          <p:nvPr/>
+        </p:nvSpPr>
+        <p:spPr>
+          <a:xfrm>
+            <a:off x="2834640" y="3374136"/>
+            <a:ext cx="3657600" cy="548640"/>
+          </a:xfrm>
+          <a:prstGeom prst="rect">
+            <a:avLst/>
+          </a:prstGeom>
+          <a:noFill/>
+        </p:spPr>
+        <p:txBody>
+          <a:bodyPr wrap="square">
+            <a:spAutoFit/>
+          </a:bodyPr>
+          <a:lstStyle/>
+          <a:p>
+            <a:pPr algn="l">
+              <a:lnSpc>
+                <a:spcPct val="110000"/>
+              </a:lnSpc>
+            </a:pPr>
+            <a:r>
+              <a:rPr sz="1300" b="0">
+                <a:solidFill>
+                  <a:srgbClr val="1C2620"/>
+                </a:solidFill>
+                <a:latin typeface="Malgun Gothic"/>
+              </a:rPr>
+              <a:t>농장 관리 플랫폼, 날씨는 부속 기능</a:t>
+            </a:r>
+          </a:p>
+        </p:txBody>
+      </p:sp>
+      <p:sp>
+        <p:nvSpPr>
+          <p:cNvPr id="17" name="TextBox 16"/>
+          <p:cNvSpPr txBox="1"/>
+          <p:nvPr/>
+        </p:nvSpPr>
+        <p:spPr>
+          <a:xfrm>
+            <a:off x="6583680" y="3374136"/>
+            <a:ext cx="1280160" cy="548640"/>
+          </a:xfrm>
+          <a:prstGeom prst="rect">
+            <a:avLst/>
+          </a:prstGeom>
+          <a:noFill/>
+        </p:spPr>
+        <p:txBody>
+          <a:bodyPr wrap="square">
+            <a:spAutoFit/>
+          </a:bodyPr>
+          <a:lstStyle/>
+          <a:p>
+            <a:pPr algn="l">
+              <a:lnSpc>
+                <a:spcPct val="110000"/>
+              </a:lnSpc>
+            </a:pPr>
+            <a:r>
+              <a:rPr sz="1300" b="0">
+                <a:solidFill>
+                  <a:srgbClr val="1C2620"/>
+                </a:solidFill>
+                <a:latin typeface="Malgun Gothic"/>
+              </a:rPr>
+              <a:t>농장</a:t>
+            </a:r>
+          </a:p>
+        </p:txBody>
+      </p:sp>
+      <p:sp>
+        <p:nvSpPr>
+          <p:cNvPr id="18" name="TextBox 17"/>
+          <p:cNvSpPr txBox="1"/>
+          <p:nvPr/>
+        </p:nvSpPr>
+        <p:spPr>
+          <a:xfrm>
+            <a:off x="7955279" y="3374136"/>
+            <a:ext cx="3657600" cy="548640"/>
+          </a:xfrm>
+          <a:prstGeom prst="rect">
+            <a:avLst/>
+          </a:prstGeom>
+          <a:noFill/>
+        </p:spPr>
+        <p:txBody>
+          <a:bodyPr wrap="square">
+            <a:spAutoFit/>
+          </a:bodyPr>
+          <a:lstStyle/>
+          <a:p>
+            <a:pPr algn="l">
+              <a:lnSpc>
+                <a:spcPct val="110000"/>
+              </a:lnSpc>
+            </a:pPr>
+            <a:r>
+              <a:rPr sz="1300" b="0">
+                <a:solidFill>
+                  <a:srgbClr val="1C2620"/>
+                </a:solidFill>
+                <a:latin typeface="Malgun Gothic"/>
+              </a:rPr>
+              <a:t>기계 데이터는 쌓이나 날씨-수확 검증 없음</a:t>
+            </a:r>
+          </a:p>
+        </p:txBody>
+      </p:sp>
+      <p:cxnSp>
+        <p:nvCxnSpPr>
+          <p:cNvPr id="19" name="Connector 18"/>
+          <p:cNvCxnSpPr/>
+          <p:nvPr/>
+        </p:nvCxnSpPr>
+        <p:spPr>
+          <a:xfrm>
+            <a:off x="548640" y="3904488"/>
+            <a:ext cx="11064240" cy="0"/>
+          </a:xfrm>
+          <a:prstGeom prst="line">
+            <a:avLst/>
+          </a:prstGeom>
+          <a:ln w="12700">
+            <a:solidFill>
+              <a:srgbClr val="C5CCC3"/>
+            </a:solidFill>
+          </a:ln>
+        </p:spPr>
+        <p:style>
+          <a:lnRef idx="2">
+            <a:schemeClr val="accent1"/>
+          </a:lnRef>
+          <a:fillRef idx="0">
+            <a:schemeClr val="accent1"/>
+          </a:fillRef>
+          <a:effectRef idx="1">
+            <a:schemeClr val="accent1"/>
+          </a:effectRef>
+          <a:fontRef idx="minor">
+            <a:schemeClr val="tx1"/>
+          </a:fontRef>
+        </p:style>
+      </p:cxnSp>
+      <p:sp>
+        <p:nvSpPr>
+          <p:cNvPr id="20" name="TextBox 19"/>
+          <p:cNvSpPr txBox="1"/>
+          <p:nvPr/>
+        </p:nvSpPr>
+        <p:spPr>
+          <a:xfrm>
+            <a:off x="548640" y="3941064"/>
+            <a:ext cx="2194560" cy="548640"/>
+          </a:xfrm>
+          <a:prstGeom prst="rect">
+            <a:avLst/>
+          </a:prstGeom>
+          <a:noFill/>
+        </p:spPr>
+        <p:txBody>
+          <a:bodyPr wrap="square">
+            <a:spAutoFit/>
+          </a:bodyPr>
+          <a:lstStyle/>
+          <a:p>
+            <a:pPr algn="l">
+              <a:lnSpc>
+                <a:spcPct val="110000"/>
+              </a:lnSpc>
+            </a:pPr>
+            <a:r>
+              <a:rPr sz="1300" b="1">
+                <a:solidFill>
+                  <a:srgbClr val="1C2620"/>
+                </a:solidFill>
+                <a:latin typeface="Malgun Gothic"/>
+              </a:rPr>
+              <a:t>RL 환경 회사</a:t>
+            </a:r>
+          </a:p>
+        </p:txBody>
+      </p:sp>
+      <p:sp>
+        <p:nvSpPr>
+          <p:cNvPr id="21" name="TextBox 20"/>
+          <p:cNvSpPr txBox="1"/>
+          <p:nvPr/>
+        </p:nvSpPr>
+        <p:spPr>
+          <a:xfrm>
+            <a:off x="2834640" y="3941064"/>
+            <a:ext cx="3657600" cy="548640"/>
+          </a:xfrm>
+          <a:prstGeom prst="rect">
+            <a:avLst/>
+          </a:prstGeom>
+          <a:noFill/>
+        </p:spPr>
+        <p:txBody>
+          <a:bodyPr wrap="square">
+            <a:spAutoFit/>
+          </a:bodyPr>
+          <a:lstStyle/>
+          <a:p>
+            <a:pPr algn="l">
+              <a:lnSpc>
+                <a:spcPct val="110000"/>
+              </a:lnSpc>
+            </a:pPr>
+            <a:r>
+              <a:rPr sz="1300" b="0">
+                <a:solidFill>
+                  <a:srgbClr val="1C2620"/>
+                </a:solidFill>
+                <a:latin typeface="Malgun Gothic"/>
+              </a:rPr>
+              <a:t>랩에 파는 운영 시뮬레이션 환경</a:t>
+            </a:r>
+          </a:p>
+        </p:txBody>
+      </p:sp>
+      <p:sp>
+        <p:nvSpPr>
+          <p:cNvPr id="22" name="TextBox 21"/>
+          <p:cNvSpPr txBox="1"/>
+          <p:nvPr/>
+        </p:nvSpPr>
+        <p:spPr>
+          <a:xfrm>
+            <a:off x="6583680" y="3941064"/>
+            <a:ext cx="1280160" cy="548640"/>
+          </a:xfrm>
+          <a:prstGeom prst="rect">
+            <a:avLst/>
+          </a:prstGeom>
+          <a:noFill/>
+        </p:spPr>
+        <p:txBody>
+          <a:bodyPr wrap="square">
+            <a:spAutoFit/>
+          </a:bodyPr>
+          <a:lstStyle/>
+          <a:p>
+            <a:pPr algn="l">
+              <a:lnSpc>
+                <a:spcPct val="110000"/>
+              </a:lnSpc>
+            </a:pPr>
+            <a:r>
+              <a:rPr sz="1300" b="0">
+                <a:solidFill>
+                  <a:srgbClr val="1C2620"/>
+                </a:solidFill>
+                <a:latin typeface="Malgun Gothic"/>
+              </a:rPr>
+              <a:t>과제</a:t>
+            </a:r>
+          </a:p>
+        </p:txBody>
+      </p:sp>
+      <p:sp>
+        <p:nvSpPr>
+          <p:cNvPr id="23" name="TextBox 22"/>
+          <p:cNvSpPr txBox="1"/>
+          <p:nvPr/>
+        </p:nvSpPr>
+        <p:spPr>
+          <a:xfrm>
+            <a:off x="7955279" y="3941064"/>
+            <a:ext cx="3657600" cy="548640"/>
+          </a:xfrm>
+          <a:prstGeom prst="rect">
+            <a:avLst/>
+          </a:prstGeom>
+          <a:noFill/>
+        </p:spPr>
+        <p:txBody>
+          <a:bodyPr wrap="square">
+            <a:spAutoFit/>
+          </a:bodyPr>
+          <a:lstStyle/>
+          <a:p>
+            <a:pPr algn="l">
+              <a:lnSpc>
+                <a:spcPct val="110000"/>
+              </a:lnSpc>
+            </a:pPr>
+            <a:r>
+              <a:rPr sz="1300" b="0">
+                <a:solidFill>
+                  <a:srgbClr val="1C2620"/>
+                </a:solidFill>
+                <a:latin typeface="Malgun Gothic"/>
+              </a:rPr>
+              <a:t>날씨 실측으로 채점하는 농업 과제는 없음</a:t>
+            </a:r>
+          </a:p>
+        </p:txBody>
+      </p:sp>
+      <p:cxnSp>
+        <p:nvCxnSpPr>
+          <p:cNvPr id="24" name="Connector 23"/>
+          <p:cNvCxnSpPr/>
+          <p:nvPr/>
+        </p:nvCxnSpPr>
+        <p:spPr>
+          <a:xfrm>
+            <a:off x="548640" y="4471416"/>
+            <a:ext cx="11064240" cy="0"/>
+          </a:xfrm>
+          <a:prstGeom prst="line">
+            <a:avLst/>
+          </a:prstGeom>
+          <a:ln w="12700">
+            <a:solidFill>
+              <a:srgbClr val="C5CCC3"/>
+            </a:solidFill>
+          </a:ln>
+        </p:spPr>
+        <p:style>
+          <a:lnRef idx="2">
+            <a:schemeClr val="accent1"/>
+          </a:lnRef>
+          <a:fillRef idx="0">
+            <a:schemeClr val="accent1"/>
+          </a:fillRef>
+          <a:effectRef idx="1">
+            <a:schemeClr val="accent1"/>
+          </a:effectRef>
+          <a:fontRef idx="minor">
+            <a:schemeClr val="tx1"/>
+          </a:fontRef>
+        </p:style>
+      </p:cxnSp>
+      <p:sp>
+        <p:nvSpPr>
+          <p:cNvPr id="25" name="TextBox 24"/>
+          <p:cNvSpPr txBox="1"/>
+          <p:nvPr/>
+        </p:nvSpPr>
+        <p:spPr>
+          <a:xfrm>
+            <a:off x="548640" y="4507992"/>
+            <a:ext cx="2194560" cy="548640"/>
+          </a:xfrm>
+          <a:prstGeom prst="rect">
+            <a:avLst/>
+          </a:prstGeom>
+          <a:noFill/>
+        </p:spPr>
+        <p:txBody>
+          <a:bodyPr wrap="square">
+            <a:spAutoFit/>
+          </a:bodyPr>
+          <a:lstStyle/>
+          <a:p>
+            <a:pPr algn="l">
+              <a:lnSpc>
+                <a:spcPct val="110000"/>
+              </a:lnSpc>
+            </a:pPr>
+            <a:r>
+              <a:rPr sz="1300" b="1">
+                <a:solidFill>
+                  <a:srgbClr val="4E7A3A"/>
+                </a:solidFill>
+                <a:latin typeface="Malgun Gothic"/>
+              </a:rPr>
+              <a:t>꺄레</a:t>
+            </a:r>
+          </a:p>
+        </p:txBody>
+      </p:sp>
+      <p:sp>
+        <p:nvSpPr>
+          <p:cNvPr id="26" name="TextBox 25"/>
+          <p:cNvSpPr txBox="1"/>
+          <p:nvPr/>
+        </p:nvSpPr>
+        <p:spPr>
+          <a:xfrm>
+            <a:off x="2834640" y="4507992"/>
+            <a:ext cx="3657600" cy="548640"/>
+          </a:xfrm>
+          <a:prstGeom prst="rect">
+            <a:avLst/>
+          </a:prstGeom>
+          <a:noFill/>
+        </p:spPr>
+        <p:txBody>
+          <a:bodyPr wrap="square">
+            <a:spAutoFit/>
+          </a:bodyPr>
+          <a:lstStyle/>
+          <a:p>
+            <a:pPr algn="l">
+              <a:lnSpc>
+                <a:spcPct val="110000"/>
+              </a:lnSpc>
+            </a:pPr>
+            <a:r>
+              <a:rPr sz="1300" b="1">
+                <a:solidFill>
+                  <a:srgbClr val="4E7A3A"/>
+                </a:solidFill>
+                <a:latin typeface="Malgun Gothic"/>
+              </a:rPr>
+              <a:t>실측으로 채점된 농업 결정 과제 + 필지 수확 기록</a:t>
+            </a:r>
+          </a:p>
+        </p:txBody>
+      </p:sp>
+      <p:sp>
+        <p:nvSpPr>
+          <p:cNvPr id="27" name="TextBox 26"/>
+          <p:cNvSpPr txBox="1"/>
+          <p:nvPr/>
+        </p:nvSpPr>
+        <p:spPr>
+          <a:xfrm>
+            <a:off x="6583680" y="4507992"/>
+            <a:ext cx="1280160" cy="548640"/>
+          </a:xfrm>
+          <a:prstGeom prst="rect">
+            <a:avLst/>
+          </a:prstGeom>
+          <a:noFill/>
+        </p:spPr>
+        <p:txBody>
+          <a:bodyPr wrap="square">
+            <a:spAutoFit/>
+          </a:bodyPr>
+          <a:lstStyle/>
+          <a:p>
+            <a:pPr algn="l">
+              <a:lnSpc>
+                <a:spcPct val="110000"/>
+              </a:lnSpc>
+            </a:pPr>
+            <a:r>
+              <a:rPr sz="1300" b="1">
+                <a:solidFill>
+                  <a:srgbClr val="4E7A3A"/>
+                </a:solidFill>
+                <a:latin typeface="Malgun Gothic"/>
+              </a:rPr>
+              <a:t>필지·과제</a:t>
+            </a:r>
+          </a:p>
+        </p:txBody>
+      </p:sp>
+      <p:sp>
+        <p:nvSpPr>
+          <p:cNvPr id="28" name="TextBox 27"/>
+          <p:cNvSpPr txBox="1"/>
+          <p:nvPr/>
+        </p:nvSpPr>
+        <p:spPr>
+          <a:xfrm>
+            <a:off x="7955279" y="4507992"/>
+            <a:ext cx="3657600" cy="548640"/>
+          </a:xfrm>
+          <a:prstGeom prst="rect">
+            <a:avLst/>
+          </a:prstGeom>
+          <a:noFill/>
+        </p:spPr>
+        <p:txBody>
+          <a:bodyPr wrap="square">
+            <a:spAutoFit/>
+          </a:bodyPr>
+          <a:lstStyle/>
+          <a:p>
+            <a:pPr algn="l">
+              <a:lnSpc>
+                <a:spcPct val="110000"/>
+              </a:lnSpc>
+            </a:pPr>
+            <a:r>
+              <a:rPr sz="1300" b="1">
+                <a:solidFill>
+                  <a:srgbClr val="4E7A3A"/>
+                </a:solidFill>
+                <a:latin typeface="Malgun Gothic"/>
+              </a:rPr>
+              <a:t>실제 수확으로 다시 학습, 오차가 줄어듦</a:t>
+            </a:r>
+          </a:p>
+        </p:txBody>
+      </p:sp>
+      <p:cxnSp>
+        <p:nvCxnSpPr>
+          <p:cNvPr id="29" name="Connector 28"/>
+          <p:cNvCxnSpPr/>
+          <p:nvPr/>
+        </p:nvCxnSpPr>
+        <p:spPr>
+          <a:xfrm>
+            <a:off x="548640" y="5038344"/>
+            <a:ext cx="11064240" cy="0"/>
+          </a:xfrm>
+          <a:prstGeom prst="line">
+            <a:avLst/>
+          </a:prstGeom>
+          <a:ln w="12700">
+            <a:solidFill>
+              <a:srgbClr val="C5CCC3"/>
+            </a:solidFill>
+          </a:ln>
+        </p:spPr>
+        <p:style>
+          <a:lnRef idx="2">
+            <a:schemeClr val="accent1"/>
+          </a:lnRef>
+          <a:fillRef idx="0">
+            <a:schemeClr val="accent1"/>
+          </a:fillRef>
+          <a:effectRef idx="1">
+            <a:schemeClr val="accent1"/>
+          </a:effectRef>
+          <a:fontRef idx="minor">
+            <a:schemeClr val="tx1"/>
+          </a:fontRef>
+        </p:style>
+      </p:cxnSp>
+      <p:sp>
+        <p:nvSpPr>
+          <p:cNvPr id="30" name="TextBox 29"/>
+          <p:cNvSpPr txBox="1"/>
+          <p:nvPr/>
+        </p:nvSpPr>
+        <p:spPr>
+          <a:xfrm>
+            <a:off x="548640" y="5212080"/>
+            <a:ext cx="5760720" cy="731520"/>
+          </a:xfrm>
+          <a:prstGeom prst="rect">
+            <a:avLst/>
+          </a:prstGeom>
+          <a:noFill/>
+        </p:spPr>
+        <p:txBody>
+          <a:bodyPr wrap="square">
+            <a:spAutoFit/>
+          </a:bodyPr>
+          <a:lstStyle/>
+          <a:p>
+            <a:pPr algn="l">
+              <a:lnSpc>
+                <a:spcPct val="110000"/>
+              </a:lnSpc>
+            </a:pPr>
+            <a:r>
+              <a:rPr sz="3400" b="1">
+                <a:solidFill>
+                  <a:srgbClr val="7A4A2A"/>
+                </a:solidFill>
+                <a:latin typeface="Malgun Gothic"/>
+              </a:rPr>
+              <a:t>25–31%</a:t>
+            </a:r>
+          </a:p>
+        </p:txBody>
+      </p:sp>
+      <p:sp>
+        <p:nvSpPr>
+          <p:cNvPr id="31" name="TextBox 30"/>
+          <p:cNvSpPr txBox="1"/>
+          <p:nvPr/>
+        </p:nvSpPr>
+        <p:spPr>
+          <a:xfrm>
+            <a:off x="548640" y="5870448"/>
+            <a:ext cx="5760720" cy="457200"/>
+          </a:xfrm>
+          <a:prstGeom prst="rect">
+            <a:avLst/>
+          </a:prstGeom>
+          <a:noFill/>
+        </p:spPr>
+        <p:txBody>
+          <a:bodyPr wrap="square">
+            <a:spAutoFit/>
+          </a:bodyPr>
+          <a:lstStyle/>
+          <a:p>
+            <a:pPr algn="l">
+              <a:lnSpc>
+                <a:spcPct val="110000"/>
+              </a:lnSpc>
+            </a:pPr>
+            <a:r>
+              <a:rPr sz="1100" b="0">
+                <a:solidFill>
+                  <a:srgbClr val="4A5650"/>
+                </a:solidFill>
+                <a:latin typeface="Malgun Gothic"/>
+              </a:rPr>
+              <a:t>공개 예보 4개의 살포 판단이 실측과 어긋난 비율 (실데이터, 2026 여름 디모인 1,012건)</a:t>
+            </a:r>
+          </a:p>
+        </p:txBody>
+      </p:sp>
+      <p:sp>
+        <p:nvSpPr>
+          <p:cNvPr id="32" name="TextBox 31"/>
+          <p:cNvSpPr txBox="1"/>
+          <p:nvPr/>
+        </p:nvSpPr>
+        <p:spPr>
+          <a:xfrm>
+            <a:off x="6583680" y="5257800"/>
+            <a:ext cx="5029200" cy="914400"/>
+          </a:xfrm>
+          <a:prstGeom prst="rect">
+            <a:avLst/>
+          </a:prstGeom>
+          <a:noFill/>
+        </p:spPr>
+        <p:txBody>
+          <a:bodyPr wrap="square">
+            <a:spAutoFit/>
+          </a:bodyPr>
+          <a:lstStyle/>
+          <a:p>
+            <a:pPr algn="l">
+              <a:lnSpc>
+                <a:spcPct val="110000"/>
+              </a:lnSpc>
+            </a:pPr>
+            <a:r>
+              <a:rPr sz="1300" b="1">
+                <a:solidFill>
+                  <a:srgbClr val="1C2620"/>
+                </a:solidFill>
+                <a:latin typeface="Malgun Gothic"/>
+              </a:rPr>
+              <a:t>공개 날씨·보험 자료는 누구나 쓴다.</a:t>
+            </a:r>
+          </a:p>
+          <a:p>
+            <a:pPr algn="l">
+              <a:lnSpc>
+                <a:spcPct val="110000"/>
+              </a:lnSpc>
+            </a:pPr>
+            <a:r>
+              <a:rPr sz="1300" b="1">
+                <a:solidFill>
+                  <a:srgbClr val="1C2620"/>
+                </a:solidFill>
+                <a:latin typeface="Malgun Gothic"/>
+              </a:rPr>
+              <a:t>연결 농장의 필지별 수확 기록은 우리만 갖고, 해마다 쌓인다.</a:t>
+            </a:r>
+          </a:p>
+        </p:txBody>
+      </p:sp>
+      <p:sp>
+        <p:nvSpPr>
+          <p:cNvPr id="33" name="TextBox 32"/>
+          <p:cNvSpPr txBox="1"/>
+          <p:nvPr/>
+        </p:nvSpPr>
+        <p:spPr>
+          <a:xfrm>
+            <a:off x="548640" y="6355080"/>
+            <a:ext cx="11064240" cy="365760"/>
+          </a:xfrm>
+          <a:prstGeom prst="rect">
+            <a:avLst/>
+          </a:prstGeom>
+          <a:noFill/>
+        </p:spPr>
+        <p:txBody>
+          <a:bodyPr wrap="square">
+            <a:spAutoFit/>
+          </a:bodyPr>
+          <a:lstStyle/>
+          <a:p>
+            <a:pPr algn="l">
+              <a:lnSpc>
+                <a:spcPct val="110000"/>
+              </a:lnSpc>
+            </a:pPr>
+            <a:r>
+              <a:rPr sz="900" b="0">
+                <a:solidFill>
+                  <a:srgbClr val="4A5650"/>
+                </a:solidFill>
+                <a:latin typeface="Malgun Gothic"/>
+              </a:rPr>
+              <a:t>출처: docs/research_sungho/01_competitors.md, 10_similar_companies.md (RL 환경 회사 예: Maingen. 공개 자료, 일부 2차 출처). 백테스트: scripts/backtest-spray-windows.ts (Open-Meteo Single Runs, IEM ASOS DSM).</a:t>
+            </a:r>
+          </a:p>
+        </p:txBody>
+      </p:sp>
+    </p:spTree>
+  </p:cSld>
+  <p:clrMapOvr>
+    <a:masterClrMapping/>
+  </p:clrMapOvr>
+</p:sld>
+</file>
+
+<file path=ppt/slides/slide4.xml><?xml version="1.0" encoding="utf-8"?>
+<p:sld xmlns:a="http://schemas.openxmlformats.org/drawingml/2006/main" xmlns:p="http://schemas.openxmlformats.org/presentationml/2006/main" xmlns:r="http://schemas.openxmlformats.org/officeDocument/2006/relationships">
+  <p:cSld>
+    <p:bg>
+      <p:bgPr>
+        <a:solidFill>
+          <a:srgbClr val="E9ECE6"/>
+        </a:solidFill>
+        <a:effectLst/>
+      </p:bgPr>
+    </p:bg>
+    <p:spTree>
+      <p:nvGrpSpPr>
+        <p:cNvPr id="1" name=""/>
+        <p:cNvGrpSpPr/>
+        <p:nvPr/>
+      </p:nvGrpSpPr>
+      <p:grpSpPr/>
+      <p:sp>
+        <p:nvSpPr>
+          <p:cNvPr id="2" name="TextBox 1"/>
+          <p:cNvSpPr txBox="1"/>
+          <p:nvPr/>
+        </p:nvSpPr>
+        <p:spPr>
+          <a:xfrm>
+            <a:off x="548640" y="320040"/>
+            <a:ext cx="7315200" cy="365760"/>
+          </a:xfrm>
+          <a:prstGeom prst="rect">
+            <a:avLst/>
+          </a:prstGeom>
+          <a:noFill/>
+        </p:spPr>
+        <p:txBody>
+          <a:bodyPr wrap="square">
+            <a:spAutoFit/>
+          </a:bodyPr>
+          <a:lstStyle/>
+          <a:p>
+            <a:pPr algn="l">
+              <a:lnSpc>
+                <a:spcPct val="110000"/>
+              </a:lnSpc>
+            </a:pPr>
+            <a:r>
+              <a:rPr sz="1200" b="1">
+                <a:solidFill>
+                  <a:srgbClr val="4A5650"/>
+                </a:solidFill>
+                <a:latin typeface="Malgun Gothic"/>
+              </a:rPr>
+              <a:t>Weather Decision Gym · 꺄레</a:t>
+            </a:r>
+          </a:p>
+        </p:txBody>
+      </p:sp>
+      <p:cxnSp>
+        <p:nvCxnSpPr>
+          <p:cNvPr id="3" name="Connector 2"/>
+          <p:cNvCxnSpPr/>
+          <p:nvPr/>
+        </p:nvCxnSpPr>
+        <p:spPr>
+          <a:xfrm>
+            <a:off x="548640" y="731520"/>
+            <a:ext cx="11064240" cy="0"/>
+          </a:xfrm>
+          <a:prstGeom prst="line">
+            <a:avLst/>
+          </a:prstGeom>
+          <a:ln w="25400">
+            <a:solidFill>
+              <a:srgbClr val="1C2620"/>
+            </a:solidFill>
+          </a:ln>
+        </p:spPr>
+        <p:style>
+          <a:lnRef idx="2">
+            <a:schemeClr val="accent1"/>
+          </a:lnRef>
+          <a:fillRef idx="0">
+            <a:schemeClr val="accent1"/>
+          </a:fillRef>
+          <a:effectRef idx="1">
+            <a:schemeClr val="accent1"/>
+          </a:effectRef>
+          <a:fontRef idx="minor">
+            <a:schemeClr val="tx1"/>
+          </a:fontRef>
+        </p:style>
+      </p:cxnSp>
+      <p:sp>
+        <p:nvSpPr>
+          <p:cNvPr id="4" name="TextBox 3"/>
+          <p:cNvSpPr txBox="1"/>
+          <p:nvPr/>
+        </p:nvSpPr>
+        <p:spPr>
+          <a:xfrm>
+            <a:off x="548640" y="868680"/>
+            <a:ext cx="11064240" cy="731520"/>
+          </a:xfrm>
+          <a:prstGeom prst="rect">
+            <a:avLst/>
+          </a:prstGeom>
+          <a:noFill/>
+        </p:spPr>
+        <p:txBody>
+          <a:bodyPr wrap="square">
+            <a:spAutoFit/>
+          </a:bodyPr>
+          <a:lstStyle/>
+          <a:p>
+            <a:pPr algn="l">
+              <a:lnSpc>
+                <a:spcPct val="110000"/>
+              </a:lnSpc>
+            </a:pPr>
+            <a:r>
+              <a:rPr sz="2800" b="1">
+                <a:solidFill>
+                  <a:srgbClr val="1C2620"/>
+                </a:solidFill>
+                <a:latin typeface="Malgun Gothic"/>
+              </a:rPr>
+              <a:t>지금 팔 수 있는 것부터 팔고, 농장 기록으로 해자를 쌓는다</a:t>
+            </a:r>
+          </a:p>
+        </p:txBody>
+      </p:sp>
+      <p:sp>
+        <p:nvSpPr>
+          <p:cNvPr id="5" name="Rectangle 4"/>
+          <p:cNvSpPr/>
+          <p:nvPr/>
+        </p:nvSpPr>
+        <p:spPr>
+          <a:xfrm>
+            <a:off x="548640" y="1783080"/>
+            <a:ext cx="73152" cy="3291840"/>
+          </a:xfrm>
+          <a:prstGeom prst="rect">
+            <a:avLst/>
+          </a:prstGeom>
+          <a:solidFill>
+            <a:srgbClr val="3B6A94"/>
+          </a:solidFill>
+          <a:ln>
+            <a:noFill/>
+          </a:ln>
+        </p:spPr>
+        <p:style>
+          <a:lnRef idx="1">
+            <a:schemeClr val="accent1"/>
+          </a:lnRef>
+          <a:fillRef idx="3">
+            <a:schemeClr val="accent1"/>
+          </a:fillRef>
+          <a:effectRef idx="2">
+            <a:schemeClr val="accent1"/>
+          </a:effectRef>
+          <a:fontRef idx="minor">
+            <a:schemeClr val="lt1"/>
+          </a:fontRef>
+        </p:style>
+        <p:txBody>
+          <a:bodyPr rtlCol="0" anchor="ctr"/>
+          <a:lstStyle/>
+          <a:p>
+            <a:pPr algn="ctr"/>
+          </a:p>
+        </p:txBody>
+      </p:sp>
+      <p:sp>
+        <p:nvSpPr>
+          <p:cNvPr id="6" name="TextBox 5"/>
+          <p:cNvSpPr txBox="1"/>
+          <p:nvPr/>
+        </p:nvSpPr>
+        <p:spPr>
+          <a:xfrm>
+            <a:off x="777240" y="1737360"/>
+            <a:ext cx="3383280" cy="365760"/>
+          </a:xfrm>
+          <a:prstGeom prst="rect">
+            <a:avLst/>
+          </a:prstGeom>
+          <a:noFill/>
+        </p:spPr>
+        <p:txBody>
+          <a:bodyPr wrap="square">
+            <a:spAutoFit/>
+          </a:bodyPr>
+          <a:lstStyle/>
+          <a:p>
+            <a:pPr algn="l">
+              <a:lnSpc>
+                <a:spcPct val="110000"/>
+              </a:lnSpc>
+            </a:pPr>
+            <a:r>
+              <a:rPr sz="1200" b="1">
+                <a:solidFill>
+                  <a:srgbClr val="4A5650"/>
+                </a:solidFill>
+                <a:latin typeface="Malgun Gothic"/>
+              </a:rPr>
+              <a:t>1단계 · 지금</a:t>
+            </a:r>
+          </a:p>
+        </p:txBody>
+      </p:sp>
+      <p:sp>
+        <p:nvSpPr>
+          <p:cNvPr id="7" name="TextBox 6"/>
+          <p:cNvSpPr txBox="1"/>
+          <p:nvPr/>
+        </p:nvSpPr>
+        <p:spPr>
+          <a:xfrm>
+            <a:off x="777240" y="2103120"/>
+            <a:ext cx="3383280" cy="731520"/>
+          </a:xfrm>
+          <a:prstGeom prst="rect">
+            <a:avLst/>
+          </a:prstGeom>
+          <a:noFill/>
+        </p:spPr>
+        <p:txBody>
+          <a:bodyPr wrap="square">
+            <a:spAutoFit/>
+          </a:bodyPr>
+          <a:lstStyle/>
+          <a:p>
+            <a:pPr algn="l">
+              <a:lnSpc>
+                <a:spcPct val="110000"/>
+              </a:lnSpc>
+            </a:pPr>
+            <a:r>
+              <a:rPr sz="1800" b="1">
+                <a:solidFill>
+                  <a:srgbClr val="1C2620"/>
+                </a:solidFill>
+                <a:latin typeface="Malgun Gothic"/>
+              </a:rPr>
+              <a:t>RL 평가·데이터 회사</a:t>
+            </a:r>
+          </a:p>
+        </p:txBody>
+      </p:sp>
+      <p:sp>
+        <p:nvSpPr>
+          <p:cNvPr id="8" name="TextBox 7"/>
+          <p:cNvSpPr txBox="1"/>
+          <p:nvPr/>
+        </p:nvSpPr>
+        <p:spPr>
+          <a:xfrm>
+            <a:off x="777240" y="2926080"/>
+            <a:ext cx="3383280" cy="2103120"/>
+          </a:xfrm>
+          <a:prstGeom prst="rect">
+            <a:avLst/>
+          </a:prstGeom>
+          <a:noFill/>
+        </p:spPr>
+        <p:txBody>
+          <a:bodyPr wrap="square">
+            <a:spAutoFit/>
+          </a:bodyPr>
+          <a:lstStyle/>
+          <a:p>
+            <a:pPr algn="l">
+              <a:lnSpc>
+                <a:spcPct val="130000"/>
+              </a:lnSpc>
+            </a:pPr>
+            <a:r>
+              <a:rPr sz="1200" b="0">
+                <a:solidFill>
+                  <a:srgbClr val="1C2620"/>
+                </a:solidFill>
+                <a:latin typeface="Malgun Gothic"/>
+              </a:rPr>
+              <a:t>공개 예보와 실측으로 만드는 채점 과제와 비공개 평가셋</a:t>
+            </a:r>
+          </a:p>
+          <a:p>
+            <a:pPr algn="l">
+              <a:lnSpc>
+                <a:spcPct val="130000"/>
+              </a:lnSpc>
+            </a:pPr>
+            <a:r>
+              <a:rPr sz="1200" b="0">
+                <a:solidFill>
+                  <a:srgbClr val="1C2620"/>
+                </a:solidFill>
+                <a:latin typeface="Malgun Gothic"/>
+              </a:rPr>
+              <a:t>가격: 과제당 $200-2,000 시장 단가 (Epoch AI)</a:t>
+            </a:r>
+          </a:p>
+          <a:p>
+            <a:pPr algn="l">
+              <a:lnSpc>
+                <a:spcPct val="130000"/>
+              </a:lnSpc>
+            </a:pPr>
+            <a:r>
+              <a:rPr sz="1200" b="0">
+                <a:solidFill>
+                  <a:srgbClr val="1C2620"/>
+                </a:solidFill>
+                <a:latin typeface="Malgun Gothic"/>
+              </a:rPr>
+              <a:t>근거: 공개 예보 4개가 살포 판단 25–31%를 틀림 (실데이터)</a:t>
+            </a:r>
+          </a:p>
+        </p:txBody>
+      </p:sp>
+      <p:sp>
+        <p:nvSpPr>
+          <p:cNvPr id="9" name="Rectangle 8"/>
+          <p:cNvSpPr/>
+          <p:nvPr/>
+        </p:nvSpPr>
+        <p:spPr>
+          <a:xfrm>
+            <a:off x="4297679" y="1783080"/>
+            <a:ext cx="73152" cy="3291840"/>
+          </a:xfrm>
+          <a:prstGeom prst="rect">
+            <a:avLst/>
+          </a:prstGeom>
+          <a:solidFill>
+            <a:srgbClr val="C99A1E"/>
+          </a:solidFill>
+          <a:ln>
+            <a:noFill/>
+          </a:ln>
+        </p:spPr>
+        <p:style>
+          <a:lnRef idx="1">
+            <a:schemeClr val="accent1"/>
+          </a:lnRef>
+          <a:fillRef idx="3">
+            <a:schemeClr val="accent1"/>
+          </a:fillRef>
+          <a:effectRef idx="2">
+            <a:schemeClr val="accent1"/>
+          </a:effectRef>
+          <a:fontRef idx="minor">
+            <a:schemeClr val="lt1"/>
+          </a:fontRef>
+        </p:style>
+        <p:txBody>
+          <a:bodyPr rtlCol="0" anchor="ctr"/>
+          <a:lstStyle/>
+          <a:p>
+            <a:pPr algn="ctr"/>
+          </a:p>
+        </p:txBody>
+      </p:sp>
+      <p:sp>
+        <p:nvSpPr>
+          <p:cNvPr id="10" name="TextBox 9"/>
+          <p:cNvSpPr txBox="1"/>
+          <p:nvPr/>
+        </p:nvSpPr>
+        <p:spPr>
+          <a:xfrm>
+            <a:off x="4526279" y="1737360"/>
+            <a:ext cx="3383280" cy="365760"/>
+          </a:xfrm>
+          <a:prstGeom prst="rect">
+            <a:avLst/>
+          </a:prstGeom>
+          <a:noFill/>
+        </p:spPr>
+        <p:txBody>
+          <a:bodyPr wrap="square">
+            <a:spAutoFit/>
+          </a:bodyPr>
+          <a:lstStyle/>
+          <a:p>
+            <a:pPr algn="l">
+              <a:lnSpc>
+                <a:spcPct val="110000"/>
+              </a:lnSpc>
+            </a:pPr>
+            <a:r>
+              <a:rPr sz="1200" b="1">
+                <a:solidFill>
+                  <a:srgbClr val="4A5650"/>
+                </a:solidFill>
+                <a:latin typeface="Malgun Gothic"/>
+              </a:rPr>
+              <a:t>2단계 · 0~6개월</a:t>
+            </a:r>
+          </a:p>
+        </p:txBody>
+      </p:sp>
+      <p:sp>
+        <p:nvSpPr>
+          <p:cNvPr id="11" name="TextBox 10"/>
+          <p:cNvSpPr txBox="1"/>
+          <p:nvPr/>
+        </p:nvSpPr>
+        <p:spPr>
+          <a:xfrm>
+            <a:off x="4526279" y="2103120"/>
+            <a:ext cx="3383280" cy="731520"/>
+          </a:xfrm>
+          <a:prstGeom prst="rect">
+            <a:avLst/>
+          </a:prstGeom>
+          <a:noFill/>
+        </p:spPr>
+        <p:txBody>
+          <a:bodyPr wrap="square">
+            <a:spAutoFit/>
+          </a:bodyPr>
+          <a:lstStyle/>
+          <a:p>
+            <a:pPr algn="l">
+              <a:lnSpc>
+                <a:spcPct val="110000"/>
+              </a:lnSpc>
+            </a:pPr>
+            <a:r>
+              <a:rPr sz="1800" b="1">
+                <a:solidFill>
+                  <a:srgbClr val="1C2620"/>
+                </a:solidFill>
+                <a:latin typeface="Malgun Gothic"/>
+              </a:rPr>
+              <a:t>아이오와 옥수수·콩 대형 농장 10곳 (무료)</a:t>
+            </a:r>
+          </a:p>
+        </p:txBody>
+      </p:sp>
+      <p:sp>
+        <p:nvSpPr>
+          <p:cNvPr id="12" name="TextBox 11"/>
+          <p:cNvSpPr txBox="1"/>
+          <p:nvPr/>
+        </p:nvSpPr>
+        <p:spPr>
+          <a:xfrm>
+            <a:off x="4526279" y="2926080"/>
+            <a:ext cx="3383280" cy="2103120"/>
+          </a:xfrm>
+          <a:prstGeom prst="rect">
+            <a:avLst/>
+          </a:prstGeom>
+          <a:noFill/>
+        </p:spPr>
+        <p:txBody>
+          <a:bodyPr wrap="square">
+            <a:spAutoFit/>
+          </a:bodyPr>
+          <a:lstStyle/>
+          <a:p>
+            <a:pPr algn="l">
+              <a:lnSpc>
+                <a:spcPct val="130000"/>
+              </a:lnSpc>
+            </a:pPr>
+            <a:r>
+              <a:rPr sz="1200" b="0">
+                <a:solidFill>
+                  <a:srgbClr val="1C2620"/>
+                </a:solidFill>
+                <a:latin typeface="Malgun Gothic"/>
+              </a:rPr>
+              <a:t>수확 기록을 연결하면 필지별 예측을 무료로 준다</a:t>
+            </a:r>
+          </a:p>
+          <a:p>
+            <a:pPr algn="l">
+              <a:lnSpc>
+                <a:spcPct val="130000"/>
+              </a:lnSpc>
+            </a:pPr>
+            <a:r>
+              <a:rPr sz="1200" b="0">
+                <a:solidFill>
+                  <a:srgbClr val="1C2620"/>
+                </a:solidFill>
+                <a:latin typeface="Malgun Gothic"/>
+              </a:rPr>
+              <a:t>경로: 보험 가입 생산 기록(APH), Deere·FieldView 연결 (농가 동의)</a:t>
+            </a:r>
+          </a:p>
+          <a:p>
+            <a:pPr algn="l">
+              <a:lnSpc>
+                <a:spcPct val="130000"/>
+              </a:lnSpc>
+            </a:pPr>
+            <a:r>
+              <a:rPr sz="1200" b="0">
+                <a:solidFill>
+                  <a:srgbClr val="1C2620"/>
+                </a:solidFill>
+                <a:latin typeface="Malgun Gothic"/>
+              </a:rPr>
+              <a:t>목표: 필지 500곳 × 과거 3시즌 수확 기록</a:t>
+            </a:r>
+          </a:p>
+        </p:txBody>
+      </p:sp>
+      <p:sp>
+        <p:nvSpPr>
+          <p:cNvPr id="13" name="Rectangle 12"/>
+          <p:cNvSpPr/>
+          <p:nvPr/>
+        </p:nvSpPr>
+        <p:spPr>
+          <a:xfrm>
+            <a:off x="8046719" y="1783080"/>
+            <a:ext cx="73152" cy="3291840"/>
+          </a:xfrm>
+          <a:prstGeom prst="rect">
+            <a:avLst/>
+          </a:prstGeom>
+          <a:solidFill>
+            <a:srgbClr val="7A4A2A"/>
+          </a:solidFill>
+          <a:ln>
+            <a:noFill/>
+          </a:ln>
+        </p:spPr>
+        <p:style>
+          <a:lnRef idx="1">
+            <a:schemeClr val="accent1"/>
+          </a:lnRef>
+          <a:fillRef idx="3">
+            <a:schemeClr val="accent1"/>
+          </a:fillRef>
+          <a:effectRef idx="2">
+            <a:schemeClr val="accent1"/>
+          </a:effectRef>
+          <a:fontRef idx="minor">
+            <a:schemeClr val="lt1"/>
+          </a:fontRef>
+        </p:style>
+        <p:txBody>
+          <a:bodyPr rtlCol="0" anchor="ctr"/>
+          <a:lstStyle/>
+          <a:p>
+            <a:pPr algn="ctr"/>
+          </a:p>
+        </p:txBody>
+      </p:sp>
+      <p:sp>
+        <p:nvSpPr>
+          <p:cNvPr id="14" name="TextBox 13"/>
+          <p:cNvSpPr txBox="1"/>
+          <p:nvPr/>
+        </p:nvSpPr>
+        <p:spPr>
+          <a:xfrm>
+            <a:off x="8275319" y="1737360"/>
+            <a:ext cx="3383280" cy="365760"/>
+          </a:xfrm>
+          <a:prstGeom prst="rect">
+            <a:avLst/>
+          </a:prstGeom>
+          <a:noFill/>
+        </p:spPr>
+        <p:txBody>
+          <a:bodyPr wrap="square">
+            <a:spAutoFit/>
+          </a:bodyPr>
+          <a:lstStyle/>
+          <a:p>
+            <a:pPr algn="l">
+              <a:lnSpc>
+                <a:spcPct val="110000"/>
+              </a:lnSpc>
+            </a:pPr>
+            <a:r>
+              <a:rPr sz="1200" b="1">
+                <a:solidFill>
+                  <a:srgbClr val="4A5650"/>
+                </a:solidFill>
+                <a:latin typeface="Malgun Gothic"/>
+              </a:rPr>
+              <a:t>3단계 · 6~12개월</a:t>
+            </a:r>
+          </a:p>
+        </p:txBody>
+      </p:sp>
+      <p:sp>
+        <p:nvSpPr>
+          <p:cNvPr id="15" name="TextBox 14"/>
+          <p:cNvSpPr txBox="1"/>
+          <p:nvPr/>
+        </p:nvSpPr>
+        <p:spPr>
+          <a:xfrm>
+            <a:off x="8275319" y="2103120"/>
+            <a:ext cx="3383280" cy="731520"/>
+          </a:xfrm>
+          <a:prstGeom prst="rect">
+            <a:avLst/>
+          </a:prstGeom>
+          <a:noFill/>
+        </p:spPr>
+        <p:txBody>
+          <a:bodyPr wrap="square">
+            <a:spAutoFit/>
+          </a:bodyPr>
+          <a:lstStyle/>
+          <a:p>
+            <a:pPr algn="l">
+              <a:lnSpc>
+                <a:spcPct val="110000"/>
+              </a:lnSpc>
+            </a:pPr>
+            <a:r>
+              <a:rPr sz="1800" b="1">
+                <a:solidFill>
+                  <a:srgbClr val="1C2620"/>
+                </a:solidFill>
+                <a:latin typeface="Malgun Gothic"/>
+              </a:rPr>
+              <a:t>작물보험사 1곳 파일럿</a:t>
+            </a:r>
+          </a:p>
+        </p:txBody>
+      </p:sp>
+      <p:sp>
+        <p:nvSpPr>
+          <p:cNvPr id="16" name="TextBox 15"/>
+          <p:cNvSpPr txBox="1"/>
+          <p:nvPr/>
+        </p:nvSpPr>
+        <p:spPr>
+          <a:xfrm>
+            <a:off x="8275319" y="2926080"/>
+            <a:ext cx="3383280" cy="2103120"/>
+          </a:xfrm>
+          <a:prstGeom prst="rect">
+            <a:avLst/>
+          </a:prstGeom>
+          <a:noFill/>
+        </p:spPr>
+        <p:txBody>
+          <a:bodyPr wrap="square">
+            <a:spAutoFit/>
+          </a:bodyPr>
+          <a:lstStyle/>
+          <a:p>
+            <a:pPr algn="l">
+              <a:lnSpc>
+                <a:spcPct val="130000"/>
+              </a:lnSpc>
+            </a:pPr>
+            <a:r>
+              <a:rPr sz="1200" b="0">
+                <a:solidFill>
+                  <a:srgbClr val="1C2620"/>
+                </a:solidFill>
+                <a:latin typeface="Malgun Gothic"/>
+              </a:rPr>
+              <a:t>그 필지 기록으로 청구 검증, 요율 범위 제공</a:t>
+            </a:r>
+          </a:p>
+          <a:p>
+            <a:pPr algn="l">
+              <a:lnSpc>
+                <a:spcPct val="130000"/>
+              </a:lnSpc>
+            </a:pPr>
+            <a:r>
+              <a:rPr sz="1200" b="0">
+                <a:solidFill>
+                  <a:srgbClr val="1C2620"/>
+                </a:solidFill>
+                <a:latin typeface="Malgun Gothic"/>
+              </a:rPr>
+              <a:t>가격: 청구 건당 또는 acre당 [가정]</a:t>
+            </a:r>
+          </a:p>
+          <a:p>
+            <a:pPr algn="l">
+              <a:lnSpc>
+                <a:spcPct val="130000"/>
+              </a:lnSpc>
+            </a:pPr>
+            <a:r>
+              <a:rPr sz="1200" b="0">
+                <a:solidFill>
+                  <a:srgbClr val="1C2620"/>
+                </a:solidFill>
+                <a:latin typeface="Malgun Gothic"/>
+              </a:rPr>
+              <a:t>근거: 보험금의 73%가 날씨 원인</a:t>
+            </a:r>
+          </a:p>
+        </p:txBody>
+      </p:sp>
+      <p:cxnSp>
+        <p:nvCxnSpPr>
+          <p:cNvPr id="17" name="Connector 16"/>
+          <p:cNvCxnSpPr/>
+          <p:nvPr/>
+        </p:nvCxnSpPr>
+        <p:spPr>
+          <a:xfrm>
+            <a:off x="548640" y="5349240"/>
+            <a:ext cx="11064240" cy="0"/>
+          </a:xfrm>
+          <a:prstGeom prst="line">
+            <a:avLst/>
+          </a:prstGeom>
+          <a:ln w="12700">
+            <a:solidFill>
+              <a:srgbClr val="C5CCC3"/>
+            </a:solidFill>
+          </a:ln>
+        </p:spPr>
+        <p:style>
+          <a:lnRef idx="2">
+            <a:schemeClr val="accent1"/>
+          </a:lnRef>
+          <a:fillRef idx="0">
+            <a:schemeClr val="accent1"/>
+          </a:fillRef>
+          <a:effectRef idx="1">
+            <a:schemeClr val="accent1"/>
+          </a:effectRef>
+          <a:fontRef idx="minor">
+            <a:schemeClr val="tx1"/>
+          </a:fontRef>
+        </p:style>
+      </p:cxnSp>
+      <p:sp>
+        <p:nvSpPr>
+          <p:cNvPr id="18" name="TextBox 17"/>
+          <p:cNvSpPr txBox="1"/>
+          <p:nvPr/>
+        </p:nvSpPr>
+        <p:spPr>
+          <a:xfrm>
+            <a:off x="548640" y="5440680"/>
+            <a:ext cx="11064240" cy="731520"/>
+          </a:xfrm>
+          <a:prstGeom prst="rect">
+            <a:avLst/>
+          </a:prstGeom>
+          <a:noFill/>
+        </p:spPr>
+        <p:txBody>
+          <a:bodyPr wrap="square">
+            <a:spAutoFit/>
+          </a:bodyPr>
+          <a:lstStyle/>
+          <a:p>
+            <a:pPr algn="l">
+              <a:lnSpc>
+                <a:spcPct val="110000"/>
+              </a:lnSpc>
+            </a:pPr>
+            <a:r>
+              <a:rPr sz="1600" b="1">
+                <a:solidFill>
+                  <a:srgbClr val="1C2620"/>
+                </a:solidFill>
+                <a:latin typeface="Malgun Gothic"/>
+              </a:rPr>
+              <a:t>RL 회사가 지금 매출을 내고, 농장은 무료로 예측을 얻는 대신 기록을 낸다. 농장이 늘수록 예측과 과제가 좋아지는 순환이다.</a:t>
+            </a:r>
+          </a:p>
+        </p:txBody>
+      </p:sp>
+      <p:sp>
+        <p:nvSpPr>
+          <p:cNvPr id="19" name="TextBox 18"/>
+          <p:cNvSpPr txBox="1"/>
+          <p:nvPr/>
+        </p:nvSpPr>
+        <p:spPr>
+          <a:xfrm>
+            <a:off x="548640" y="6355080"/>
+            <a:ext cx="11064240" cy="365760"/>
+          </a:xfrm>
+          <a:prstGeom prst="rect">
+            <a:avLst/>
+          </a:prstGeom>
+          <a:noFill/>
+        </p:spPr>
+        <p:txBody>
+          <a:bodyPr wrap="square">
+            <a:spAutoFit/>
+          </a:bodyPr>
+          <a:lstStyle/>
+          <a:p>
+            <a:pPr algn="l">
+              <a:lnSpc>
+                <a:spcPct val="110000"/>
+              </a:lnSpc>
+            </a:pPr>
+            <a:r>
+              <a:rPr sz="900" b="0">
+                <a:solidFill>
+                  <a:srgbClr val="4A5650"/>
+                </a:solidFill>
+                <a:latin typeface="Malgun Gothic"/>
+              </a:rPr>
+              <a:t>2·3단계 숫자와 가격은 가정, APH 공유 조건과 API 약관은 확인 필요. 과제 단가: Epoch AI "An FAQ on RL environments". 보험금 비중: EWG 작물보험 분석(USDA RMA 자료).</a:t>
             </a:r>
           </a:p>
         </p:txBody>

</xml_diff>